<commit_message>
Deck: HITL P-012 (e-maile klientów) wg karty procesu
Co-Authored-By: Claude Opus 5.5 <noreply@anthropic.com>
Claude-Session: https://claude.ai/code/session_01G5YqtdXDgytrewF8H77h4S
</commit_message>
<xml_diff>
--- a/05_etap5_prezentacja/slajdy/HELVIA_deck_v1.pptx
+++ b/05_etap5_prezentacja/slajdy/HELVIA_deck_v1.pptx
@@ -668,7 +668,7 @@
           <a:lstStyle/>
           <a:p>
             <a:r>
-              <a:t>[1:50–2:40 · Analityk ludzi i ryzyk] W pierwszej fali AI bierze rutynę w trzech procesach. Rejestracja faktur działa automatycznie z wyjątkami dla człowieka — to odciąża Finanse i odblokowuje projekt dla Kastelli. Odpowiedzi na e-maile w trybie human in the loop: AI pisze szkic, człowiek zatwierdza, a każda reklamacja albo ryzyko kary SLA trafia do konsultanta. Reklamacje złożone świadomie zostawiamy ludziom — tam liczą się empatia i decyzja. Koszt technologii: ok. 295 tys. zł w pierwszym roku.</a:t>
+              <a:t>[1:50–2:40 · Analityk ludzi i ryzyk] W pierwszej fali AI bierze rutynę w trzech procesach. Rejestracja faktur działa automatycznie z wyjątkami dla człowieka — to odciąża Finanse i odblokowuje projekt dla Kastelli. Odpowiedzi na e-maile klientów projektujemy w trybie human in the loop: AI rozpoznaje sprawę i pisze szkic odpowiedzi, ale wysyłka zawsze wymaga decyzji konsultanta, a skargi, reklamacje, roszczenia i prośby o wyjątek od razu trafiają do lidera zespołu. Reklamacje złożone świadomie zostawiamy ludziom — tam liczą się empatia i decyzja. Koszt technologii: ok. 295 tys. zł w pierwszym roku.</a:t>
             </a:r>
           </a:p>
           <a:p/>
@@ -686,7 +686,7 @@
           <a:p/>
           <a:p>
             <a:r>
-              <a:t>[DO DECYZJI] Arkusze 3B i 3C są puste — procesy, tryby i % skrócenia czasu to propozycja asystenta. Prawa kolumna to szkielet na Etap 4.</a:t>
+              <a:t>[DECYZJA ZESPOŁU] Proces HITL w 3C: P-012 (e-maile klientów). [DO DECYZJI] Pozostałe procesy pierwszej fali (P-001, P-039), proces dla człowieka (P-015) i % skrócenia czasu to propozycja asystenta. Prawa kolumna to szkielet na Etap 4.</a:t>
             </a:r>
           </a:p>
         </p:txBody>
@@ -8056,7 +8056,7 @@
         <p:spPr>
           <a:xfrm>
             <a:off x="3383280" y="1700784"/>
-            <a:ext cx="2194560" cy="256032"/>
+            <a:ext cx="3520440" cy="256032"/>
           </a:xfrm>
           <a:prstGeom prst="roundRect">
             <a:avLst/>
@@ -8097,7 +8097,7 @@
                 </a:solidFill>
                 <a:latin typeface="Calibri"/>
               </a:rPr>
-              <a:t>3B / 3C DO DECYZJI</a:t>
+              <a:t>HITL: P-012 ✓  ·  P-001, P-039, P-015 DO DECYZJI</a:t>
             </a:r>
           </a:p>
         </p:txBody>
@@ -9052,7 +9052,7 @@
                 </a:solidFill>
                 <a:latin typeface="Calibri"/>
               </a:rPr>
-              <a:t>HITL dla P-012: kto decyduje</a:t>
+              <a:t>HITL dla P-012 (CRM Helios): AI przygotowuje, człowiek decyduje</a:t>
             </a:r>
           </a:p>
         </p:txBody>
@@ -9066,7 +9066,7 @@
         <p:spPr>
           <a:xfrm>
             <a:off x="502920" y="4846320"/>
-            <a:ext cx="2011680" cy="868680"/>
+            <a:ext cx="1463040" cy="914400"/>
           </a:xfrm>
           <a:prstGeom prst="rect">
             <a:avLst/>
@@ -9111,8 +9111,8 @@
         </p:nvSpPr>
         <p:spPr>
           <a:xfrm>
-            <a:off x="576072" y="4892040"/>
-            <a:ext cx="1874519" cy="822960"/>
+            <a:off x="539496" y="4873752"/>
+            <a:ext cx="1408176" cy="877824"/>
           </a:xfrm>
           <a:prstGeom prst="rect">
             <a:avLst/>
@@ -9127,25 +9127,25 @@
           <a:p>
             <a:pPr algn="l"/>
             <a:r>
-              <a:rPr sz="1200" b="1" i="0">
+              <a:rPr sz="1100" b="1" i="0">
                 <a:solidFill>
                   <a:srgbClr val="0F7C7E"/>
                 </a:solidFill>
                 <a:latin typeface="Calibri"/>
               </a:rPr>
-              <a:t>AI</a:t>
+              <a:t>1 · AI</a:t>
             </a:r>
           </a:p>
           <a:p>
             <a:pPr algn="l"/>
             <a:r>
-              <a:rPr sz="1000" b="0" i="0">
+              <a:rPr sz="850" b="0" i="0">
                 <a:solidFill>
                   <a:srgbClr val="1C2430"/>
                 </a:solidFill>
                 <a:latin typeface="Calibri"/>
               </a:rPr>
-              <a:t>klasyfikuje e-mail i pisze szkic</a:t>
+              <a:t>rozpoznaje temat, klienta i zamówienie; dzieli e-mail z kilkoma pytaniami</a:t>
             </a:r>
           </a:p>
         </p:txBody>
@@ -9158,8 +9158,8 @@
         </p:nvSpPr>
         <p:spPr>
           <a:xfrm>
-            <a:off x="2532888" y="5184648"/>
-            <a:ext cx="164592" cy="201168"/>
+            <a:off x="1975104" y="5202936"/>
+            <a:ext cx="155448" cy="182880"/>
           </a:xfrm>
           <a:prstGeom prst="rightArrow">
             <a:avLst/>
@@ -9201,8 +9201,144 @@
         </p:nvSpPr>
         <p:spPr>
           <a:xfrm>
-            <a:off x="2697480" y="4846320"/>
-            <a:ext cx="2011680" cy="868680"/>
+            <a:off x="2148840" y="4846320"/>
+            <a:ext cx="1463040" cy="914400"/>
+          </a:xfrm>
+          <a:prstGeom prst="rect">
+            <a:avLst/>
+          </a:prstGeom>
+          <a:solidFill>
+            <a:srgbClr val="FFFFFF"/>
+          </a:solidFill>
+          <a:ln w="15875">
+            <a:solidFill>
+              <a:srgbClr val="0F7C7E"/>
+            </a:solidFill>
+          </a:ln>
+          <a:effectLst/>
+        </p:spPr>
+        <p:style>
+          <a:lnRef idx="1">
+            <a:schemeClr val="accent1"/>
+          </a:lnRef>
+          <a:fillRef idx="3">
+            <a:schemeClr val="accent1"/>
+          </a:fillRef>
+          <a:effectRef idx="2">
+            <a:schemeClr val="accent1"/>
+          </a:effectRef>
+          <a:fontRef idx="minor">
+            <a:schemeClr val="lt1"/>
+          </a:fontRef>
+        </p:style>
+        <p:txBody>
+          <a:bodyPr rtlCol="0" anchor="ctr"/>
+          <a:lstStyle/>
+          <a:p>
+            <a:pPr algn="ctr"/>
+          </a:p>
+        </p:txBody>
+      </p:sp>
+      <p:sp>
+        <p:nvSpPr>
+          <p:cNvPr id="37" name="TextBox 36"/>
+          <p:cNvSpPr txBox="1"/>
+          <p:nvPr/>
+        </p:nvSpPr>
+        <p:spPr>
+          <a:xfrm>
+            <a:off x="2185416" y="4873752"/>
+            <a:ext cx="1408176" cy="877824"/>
+          </a:xfrm>
+          <a:prstGeom prst="rect">
+            <a:avLst/>
+          </a:prstGeom>
+          <a:noFill/>
+        </p:spPr>
+        <p:txBody>
+          <a:bodyPr wrap="square" anchor="t" lIns="73152" rIns="73152" tIns="36576" bIns="36576">
+            <a:spAutoFit/>
+          </a:bodyPr>
+          <a:lstStyle/>
+          <a:p>
+            <a:pPr algn="l"/>
+            <a:r>
+              <a:rPr sz="1100" b="1" i="0">
+                <a:solidFill>
+                  <a:srgbClr val="0F7C7E"/>
+                </a:solidFill>
+                <a:latin typeface="Calibri"/>
+              </a:rPr>
+              <a:t>2 · AI</a:t>
+            </a:r>
+          </a:p>
+          <a:p>
+            <a:pPr algn="l"/>
+            <a:r>
+              <a:rPr sz="850" b="0" i="0">
+                <a:solidFill>
+                  <a:srgbClr val="1C2430"/>
+                </a:solidFill>
+                <a:latin typeface="Calibri"/>
+              </a:rPr>
+              <a:t>pisze szkic z historii kontaktów i bazy gotowych odpowiedzi</a:t>
+            </a:r>
+          </a:p>
+        </p:txBody>
+      </p:sp>
+      <p:sp>
+        <p:nvSpPr>
+          <p:cNvPr id="38" name="Right Arrow 37"/>
+          <p:cNvSpPr/>
+          <p:nvPr/>
+        </p:nvSpPr>
+        <p:spPr>
+          <a:xfrm>
+            <a:off x="3621024" y="5202936"/>
+            <a:ext cx="155448" cy="182880"/>
+          </a:xfrm>
+          <a:prstGeom prst="rightArrow">
+            <a:avLst/>
+          </a:prstGeom>
+          <a:solidFill>
+            <a:srgbClr val="D5DBE2"/>
+          </a:solidFill>
+          <a:ln>
+            <a:noFill/>
+          </a:ln>
+        </p:spPr>
+        <p:style>
+          <a:lnRef idx="1">
+            <a:schemeClr val="accent1"/>
+          </a:lnRef>
+          <a:fillRef idx="3">
+            <a:schemeClr val="accent1"/>
+          </a:fillRef>
+          <a:effectRef idx="2">
+            <a:schemeClr val="accent1"/>
+          </a:effectRef>
+          <a:fontRef idx="minor">
+            <a:schemeClr val="lt1"/>
+          </a:fontRef>
+        </p:style>
+        <p:txBody>
+          <a:bodyPr rtlCol="0" anchor="ctr"/>
+          <a:lstStyle/>
+          <a:p>
+            <a:pPr algn="ctr"/>
+          </a:p>
+        </p:txBody>
+      </p:sp>
+      <p:sp>
+        <p:nvSpPr>
+          <p:cNvPr id="39" name="Rectangle 38"/>
+          <p:cNvSpPr/>
+          <p:nvPr/>
+        </p:nvSpPr>
+        <p:spPr>
+          <a:xfrm>
+            <a:off x="3794760" y="4846320"/>
+            <a:ext cx="1463040" cy="914400"/>
           </a:xfrm>
           <a:prstGeom prst="rect">
             <a:avLst/>
@@ -9241,14 +9377,14 @@
       </p:sp>
       <p:sp>
         <p:nvSpPr>
-          <p:cNvPr id="37" name="TextBox 36"/>
+          <p:cNvPr id="40" name="TextBox 39"/>
           <p:cNvSpPr txBox="1"/>
           <p:nvPr/>
         </p:nvSpPr>
         <p:spPr>
           <a:xfrm>
-            <a:off x="2770632" y="4892040"/>
-            <a:ext cx="1874519" cy="822960"/>
+            <a:off x="3831336" y="4873752"/>
+            <a:ext cx="1408176" cy="877824"/>
           </a:xfrm>
           <a:prstGeom prst="rect">
             <a:avLst/>
@@ -9263,39 +9399,39 @@
           <a:p>
             <a:pPr algn="l"/>
             <a:r>
-              <a:rPr sz="1200" b="1" i="0">
+              <a:rPr sz="1100" b="1" i="0">
                 <a:solidFill>
                   <a:srgbClr val="1F3A5F"/>
                 </a:solidFill>
                 <a:latin typeface="Calibri"/>
               </a:rPr>
-              <a:t>Człowiek</a:t>
+              <a:t>3 · Konsultant</a:t>
             </a:r>
           </a:p>
           <a:p>
             <a:pPr algn="l"/>
             <a:r>
-              <a:rPr sz="1000" b="0" i="0">
+              <a:rPr sz="850" b="0" i="0">
                 <a:solidFill>
                   <a:srgbClr val="1C2430"/>
                 </a:solidFill>
                 <a:latin typeface="Calibri"/>
               </a:rPr>
-              <a:t>zatwierdza / poprawia przed wysyłką</a:t>
-            </a:r>
-          </a:p>
-        </p:txBody>
-      </p:sp>
-      <p:sp>
-        <p:nvSpPr>
-          <p:cNvPr id="38" name="Right Arrow 37"/>
+              <a:t>zatwierdza lub poprawia — wysyłka zawsze po decyzji człowieka</a:t>
+            </a:r>
+          </a:p>
+        </p:txBody>
+      </p:sp>
+      <p:sp>
+        <p:nvSpPr>
+          <p:cNvPr id="41" name="Right Arrow 40"/>
           <p:cNvSpPr/>
           <p:nvPr/>
         </p:nvSpPr>
         <p:spPr>
           <a:xfrm>
-            <a:off x="4727448" y="5184648"/>
-            <a:ext cx="164592" cy="201168"/>
+            <a:off x="5266944" y="5202936"/>
+            <a:ext cx="155448" cy="182880"/>
           </a:xfrm>
           <a:prstGeom prst="rightArrow">
             <a:avLst/>
@@ -9331,14 +9467,14 @@
       </p:sp>
       <p:sp>
         <p:nvSpPr>
-          <p:cNvPr id="39" name="Rectangle 38"/>
+          <p:cNvPr id="42" name="Rectangle 41"/>
           <p:cNvSpPr/>
           <p:nvPr/>
         </p:nvSpPr>
         <p:spPr>
           <a:xfrm>
-            <a:off x="4892040" y="4846320"/>
-            <a:ext cx="2011680" cy="868680"/>
+            <a:off x="5440680" y="4846320"/>
+            <a:ext cx="1463040" cy="914400"/>
           </a:xfrm>
           <a:prstGeom prst="rect">
             <a:avLst/>
@@ -9377,14 +9513,14 @@
       </p:sp>
       <p:sp>
         <p:nvSpPr>
-          <p:cNvPr id="40" name="TextBox 39"/>
+          <p:cNvPr id="43" name="TextBox 42"/>
           <p:cNvSpPr txBox="1"/>
           <p:nvPr/>
         </p:nvSpPr>
         <p:spPr>
           <a:xfrm>
-            <a:off x="4965192" y="4892040"/>
-            <a:ext cx="1874519" cy="822960"/>
+            <a:off x="5477256" y="4873752"/>
+            <a:ext cx="1408176" cy="877824"/>
           </a:xfrm>
           <a:prstGeom prst="rect">
             <a:avLst/>
@@ -9399,32 +9535,32 @@
           <a:p>
             <a:pPr algn="l"/>
             <a:r>
-              <a:rPr sz="1200" b="1" i="0">
+              <a:rPr sz="1100" b="1" i="0">
                 <a:solidFill>
                   <a:srgbClr val="C77C0E"/>
                 </a:solidFill>
                 <a:latin typeface="Calibri"/>
               </a:rPr>
-              <a:t>Eskalacja</a:t>
+              <a:t>Eskalacja → lider</a:t>
             </a:r>
           </a:p>
           <a:p>
             <a:pPr algn="l"/>
             <a:r>
-              <a:rPr sz="1000" b="0" i="0">
+              <a:rPr sz="850" b="0" i="0">
                 <a:solidFill>
                   <a:srgbClr val="1C2430"/>
                 </a:solidFill>
                 <a:latin typeface="Calibri"/>
               </a:rPr>
-              <a:t>reklamacja, groźba kary SLA, klient NORDA w szczycie</a:t>
-            </a:r>
-          </a:p>
-        </p:txBody>
-      </p:sp>
-      <p:sp>
-        <p:nvSpPr>
-          <p:cNvPr id="41" name="TextBox 40"/>
+              <a:t>skarga, reklamacja, roszczenie, groźba prawna, dane osobowe, prośba o wyjątek</a:t>
+            </a:r>
+          </a:p>
+        </p:txBody>
+      </p:sp>
+      <p:sp>
+        <p:nvSpPr>
+          <p:cNvPr id="44" name="TextBox 43"/>
           <p:cNvSpPr txBox="1"/>
           <p:nvPr/>
         </p:nvSpPr>
@@ -9477,7 +9613,7 @@
       </p:sp>
       <p:sp>
         <p:nvSpPr>
-          <p:cNvPr id="42" name="Rectangle 41"/>
+          <p:cNvPr id="45" name="Rectangle 44"/>
           <p:cNvSpPr/>
           <p:nvPr/>
         </p:nvSpPr>
@@ -9521,7 +9657,7 @@
       </p:sp>
       <p:sp>
         <p:nvSpPr>
-          <p:cNvPr id="43" name="TextBox 42"/>
+          <p:cNvPr id="46" name="TextBox 45"/>
           <p:cNvSpPr txBox="1"/>
           <p:nvPr/>
         </p:nvSpPr>
@@ -9556,7 +9692,7 @@
       </p:sp>
       <p:sp>
         <p:nvSpPr>
-          <p:cNvPr id="44" name="Rounded Rectangle 43"/>
+          <p:cNvPr id="47" name="Rounded Rectangle 46"/>
           <p:cNvSpPr/>
           <p:nvPr/>
         </p:nvSpPr>
@@ -9611,7 +9747,7 @@
       </p:sp>
       <p:sp>
         <p:nvSpPr>
-          <p:cNvPr id="45" name="TextBox 44"/>
+          <p:cNvPr id="48" name="TextBox 47"/>
           <p:cNvSpPr txBox="1"/>
           <p:nvPr/>
         </p:nvSpPr>
@@ -9658,7 +9794,7 @@
       </p:sp>
       <p:sp>
         <p:nvSpPr>
-          <p:cNvPr id="46" name="TextBox 45"/>
+          <p:cNvPr id="49" name="TextBox 48"/>
           <p:cNvSpPr txBox="1"/>
           <p:nvPr/>
         </p:nvSpPr>
@@ -9702,7 +9838,7 @@
       </p:sp>
       <p:sp>
         <p:nvSpPr>
-          <p:cNvPr id="47" name="TextBox 46"/>
+          <p:cNvPr id="50" name="TextBox 49"/>
           <p:cNvSpPr txBox="1"/>
           <p:nvPr/>
         </p:nvSpPr>
@@ -9746,7 +9882,7 @@
       </p:sp>
       <p:sp>
         <p:nvSpPr>
-          <p:cNvPr id="48" name="TextBox 47"/>
+          <p:cNvPr id="51" name="TextBox 50"/>
           <p:cNvSpPr txBox="1"/>
           <p:nvPr/>
         </p:nvSpPr>
@@ -9790,7 +9926,7 @@
       </p:sp>
       <p:sp>
         <p:nvSpPr>
-          <p:cNvPr id="49" name="TextBox 48"/>
+          <p:cNvPr id="52" name="TextBox 51"/>
           <p:cNvSpPr txBox="1"/>
           <p:nvPr/>
         </p:nvSpPr>
@@ -9834,7 +9970,7 @@
       </p:sp>
       <p:sp>
         <p:nvSpPr>
-          <p:cNvPr id="50" name="TextBox 49"/>
+          <p:cNvPr id="53" name="TextBox 52"/>
           <p:cNvSpPr txBox="1"/>
           <p:nvPr/>
         </p:nvSpPr>
@@ -9878,7 +10014,7 @@
       </p:sp>
       <p:sp>
         <p:nvSpPr>
-          <p:cNvPr id="51" name="Rectangle 50"/>
+          <p:cNvPr id="54" name="Rectangle 53"/>
           <p:cNvSpPr/>
           <p:nvPr/>
         </p:nvSpPr>
@@ -9922,7 +10058,7 @@
       </p:sp>
       <p:sp>
         <p:nvSpPr>
-          <p:cNvPr id="52" name="TextBox 51"/>
+          <p:cNvPr id="55" name="TextBox 54"/>
           <p:cNvSpPr txBox="1"/>
           <p:nvPr/>
         </p:nvSpPr>

</xml_diff>

<commit_message>
E3: deck, szkic i rejestr zgodne z finalnymi decyzjami zespołu (P-014 HITL, P-012, P-001, P-015)
Co-Authored-By: Claude Opus 5.5 <noreply@anthropic.com>
Claude-Session: https://claude.ai/code/session_01G5YqtdXDgytrewF8H77h4S
</commit_message>
<xml_diff>
--- a/05_etap5_prezentacja/slajdy/HELVIA_deck_v1.pptx
+++ b/05_etap5_prezentacja/slajdy/HELVIA_deck_v1.pptx
@@ -668,13 +668,13 @@
           <a:lstStyle/>
           <a:p>
             <a:r>
-              <a:t>[1:50–2:40 · Analityk ludzi i ryzyk] W pierwszej fali AI bierze rutynę w trzech procesach. Rejestracja faktur działa automatycznie z wyjątkami dla człowieka — to odciąża Finanse i odblokowuje projekt dla Kastelli. Odpowiedzi na e-maile klientów projektujemy w trybie human in the loop: AI rozpoznaje sprawę i pisze szkic odpowiedzi, ale wysyłka zawsze wymaga decyzji konsultanta, a skargi, reklamacje, roszczenia i prośby o wyjątek od razu trafiają do lidera zespołu. Reklamacje złożone świadomie zostawiamy ludziom — tam liczą się empatia i decyzja. Koszt technologii: ok. 295 tys. zł w pierwszym roku.</a:t>
+              <a:t>[1:50–2:40 · Analityk ludzi i ryzyk] Nasza zasada brzmi: AI przygotowuje, człowiek decyduje. Wdrażamy ją tam, gdzie powstają kary — w Obsłudze Klienta, gdzie NORDA i Lumea odpowiadają za 94% kar SLA. Przy rejestracji reklamacji AI rozpoznaje klienta, przygotowuje kartę i proponuje kategorię oraz priorytet, ale każdą kwalifikację zatwierdza konsultant. Gdy AI nie jest pewne na 80%, sprawę od razu przejmuje człowiek. Bezpieczeństwo produktu, wysoka wartość i spory trafiają do specjalisty. Co tydzień sprawdzamy 10% spraw, a gdy trafność spada poniżej 90%, wyłączamy propozycje AI. Przy e-mailach AI pisze szkic, a wysyła człowiek. Faktury rejestruje automat, a wyjątki obsługują księgowi. Decyzje reklamacyjne świadomie zostawiamy ludziom. Koszt technologii to ok. 222 tys. zł z 300 tys. zł limitu.</a:t>
             </a:r>
           </a:p>
           <a:p/>
           <a:p>
             <a:r>
-              <a:t>Uwolniony czas — ok. 45 etatów — nie oznacza zwolnień. Idzie na jakość w szczytach NORDY i na nowe projekty, a zatrudnienie dopasowuje naturalna rotacja. Szkolimy Obsługę Klienta, w której dziś przeszkolonych jest 9%.</a:t>
+              <a:t>Uwalniamy ok. 36 etatów zdolności i nie oznacza to zwolnień. Ten czas idzie na szczyty NORDY i projekt dla Kastelli. Zanim ruszy pilotaż, mówimy wprost: „odciążenie, nie redukcja”. Robimy tak, bo 82% konsultantów boi się o pracę, a ten lęk najmocniej przewiduje odejścia.</a:t>
             </a:r>
           </a:p>
           <a:p/>
@@ -686,7 +686,7 @@
           <a:p/>
           <a:p>
             <a:r>
-              <a:t>[DECYZJA ZESPOŁU] Proces HITL w 3C: P-012 (e-maile klientów). [DO DECYZJI] Pozostałe procesy pierwszej fali (P-001, P-039), proces dla człowieka (P-015) i % skrócenia czasu to propozycja asystenta. Prawa kolumna to szkielet na Etap 4.</a:t>
+              <a:t>[DECYZJA ZESPOŁU — 3B/3C] P-014 (HITL, mapa 3C), P-012 (HITL, Asystent), P-001 (automatyzacja), P-015 zostaje u człowieka; hipotezy −30/−30/−50%. [DO WERYFIKACJI] 36 etatów to zdolność z hipotezy, a nie zmierzony efekt — w E4 rozpiszcie, ile idzie na szczyty i SLA, ile na S-01 (6,5 et.) i projekty kierunku (8,6 et.), a ile wchłonie rotacja. [ZAŁOŻENIE] Koszt nie obejmuje szkoleń ani czasu nadzoru (3B A41).</a:t>
             </a:r>
           </a:p>
         </p:txBody>
@@ -8007,7 +8007,7 @@
                 </a:solidFill>
                 <a:latin typeface="Calibri"/>
               </a:rPr>
-              <a:t>AI przejmuje rutynę w 3 procesach, człowiek zostaje przy decyzjach — uwolniony czas idzie w jakość i wzrost, nie w zwolnienia</a:t>
+              <a:t>AI przygotowuje, człowiek decyduje: 3 procesy z AI, reklamacje złożone zostają u ludzi — 36 etatów zdolności idzie w SLA i wzrost, nie w zwolnienia</a:t>
             </a:r>
           </a:p>
         </p:txBody>
@@ -8055,8 +8055,8 @@
         </p:nvSpPr>
         <p:spPr>
           <a:xfrm>
-            <a:off x="3383280" y="1700784"/>
-            <a:ext cx="3520440" cy="256032"/>
+            <a:off x="4069080" y="1700784"/>
+            <a:ext cx="2834640" cy="256032"/>
           </a:xfrm>
           <a:prstGeom prst="roundRect">
             <a:avLst/>
@@ -8097,7 +8097,7 @@
                 </a:solidFill>
                 <a:latin typeface="Calibri"/>
               </a:rPr>
-              <a:t>HITL: P-012 ✓  ·  P-001, P-039, P-015 DO DECYZJI</a:t>
+              <a:t>DECYZJA ZESPOŁU 3B/3C ✓</a:t>
             </a:r>
           </a:p>
         </p:txBody>
@@ -8211,7 +8211,7 @@
                 </a:solidFill>
                 <a:latin typeface="Calibri"/>
               </a:rPr>
-              <a:t>Tryb</a:t>
+              <a:t>Tryb · model</a:t>
             </a:r>
           </a:p>
         </p:txBody>
@@ -8275,7 +8275,7 @@
           <a:p>
             <a:pPr algn="l"/>
             <a:r>
-              <a:rPr sz="1050" b="1" i="0">
+              <a:rPr sz="1000" b="1" i="0">
                 <a:solidFill>
                   <a:srgbClr val="FFFFFF"/>
                 </a:solidFill>
@@ -8360,7 +8360,7 @@
                 </a:solidFill>
                 <a:latin typeface="Calibri"/>
               </a:rPr>
-              <a:t>P-001 Rejestracja faktur</a:t>
+              <a:t>P-014 Rejestracja reklamacji</a:t>
             </a:r>
           </a:p>
         </p:txBody>
@@ -8395,7 +8395,7 @@
                 </a:solidFill>
                 <a:latin typeface="Calibri"/>
               </a:rPr>
-              <a:t>Automat + wyjątki</a:t>
+              <a:t>HITL · Hybryda</a:t>
             </a:r>
           </a:p>
         </p:txBody>
@@ -8430,7 +8430,7 @@
                 </a:solidFill>
                 <a:latin typeface="Calibri"/>
               </a:rPr>
-              <a:t>3 554 (22 et.)</a:t>
+              <a:t>709 (4,4 et.)</a:t>
             </a:r>
           </a:p>
         </p:txBody>
@@ -8459,13 +8459,13 @@
           <a:p>
             <a:pPr algn="l"/>
             <a:r>
-              <a:rPr sz="1050" b="0" i="0">
+              <a:rPr sz="1000" b="0" i="0">
                 <a:solidFill>
                   <a:srgbClr val="1C2430"/>
                 </a:solidFill>
                 <a:latin typeface="Calibri"/>
               </a:rPr>
-              <a:t>Odciąża Finanse → odblokowuje S-01</a:t>
+              <a:t>Źródło kar: NORDA + Lumea = 94% kar SLA</a:t>
             </a:r>
           </a:p>
         </p:txBody>
@@ -8579,7 +8579,7 @@
                 </a:solidFill>
                 <a:latin typeface="Calibri"/>
               </a:rPr>
-              <a:t>HITL</a:t>
+              <a:t>HITL · Asystent</a:t>
             </a:r>
           </a:p>
         </p:txBody>
@@ -8614,7 +8614,7 @@
                 </a:solidFill>
                 <a:latin typeface="Calibri"/>
               </a:rPr>
-              <a:t>2 825 (18 et.)</a:t>
+              <a:t>2 119 (13,2 et.)</a:t>
             </a:r>
           </a:p>
         </p:txBody>
@@ -8643,13 +8643,13 @@
           <a:p>
             <a:pPr algn="l"/>
             <a:r>
-              <a:rPr sz="1050" b="0" i="0">
+              <a:rPr sz="1000" b="0" i="0">
                 <a:solidFill>
                   <a:srgbClr val="1C2430"/>
                 </a:solidFill>
                 <a:latin typeface="Calibri"/>
               </a:rPr>
-              <a:t>Plan SLA dla NORDY w szczytach</a:t>
+              <a:t>Największy proces OK; szybciej dla NORDY</a:t>
             </a:r>
           </a:p>
         </p:txBody>
@@ -8728,7 +8728,7 @@
                 </a:solidFill>
                 <a:latin typeface="Calibri"/>
               </a:rPr>
-              <a:t>P-039 Oferty handlowe</a:t>
+              <a:t>P-001 Rejestracja faktur</a:t>
             </a:r>
           </a:p>
         </p:txBody>
@@ -8763,7 +8763,7 @@
                 </a:solidFill>
                 <a:latin typeface="Calibri"/>
               </a:rPr>
-              <a:t>Asystent</a:t>
+              <a:t>Automat + wyjątki</a:t>
             </a:r>
           </a:p>
         </p:txBody>
@@ -8798,7 +8798,7 @@
                 </a:solidFill>
                 <a:latin typeface="Calibri"/>
               </a:rPr>
-              <a:t>854 (5 et.)</a:t>
+              <a:t>2 962 (18,5 et.)</a:t>
             </a:r>
           </a:p>
         </p:txBody>
@@ -8827,13 +8827,13 @@
           <a:p>
             <a:pPr algn="l"/>
             <a:r>
-              <a:rPr sz="1050" b="0" i="0">
+              <a:rPr sz="1000" b="0" i="0">
                 <a:solidFill>
                   <a:srgbClr val="1C2430"/>
                 </a:solidFill>
                 <a:latin typeface="Calibri"/>
               </a:rPr>
-              <a:t>Wspiera S-14 Pilawa</a:t>
+              <a:t>Odciąża Finanse przed S-01 (II kw. 2027)</a:t>
             </a:r>
           </a:p>
         </p:txBody>
@@ -9011,13 +9011,13 @@
           <a:p>
             <a:pPr algn="l"/>
             <a:r>
-              <a:rPr sz="1050" b="0" i="0">
+              <a:rPr sz="1000" b="0" i="0">
                 <a:solidFill>
                   <a:srgbClr val="1C2430"/>
                 </a:solidFill>
                 <a:latin typeface="Calibri"/>
               </a:rPr>
-              <a:t>Empatia i decyzja; 31% w OK: „trudne rozmowy”</a:t>
+              <a:t>Zasadność i ryzyko prawne; 31% OK: „trudne rozmowy”</a:t>
             </a:r>
           </a:p>
         </p:txBody>
@@ -9052,7 +9052,7 @@
                 </a:solidFill>
                 <a:latin typeface="Calibri"/>
               </a:rPr>
-              <a:t>HITL dla P-012 (CRM Helios): AI przygotowuje, człowiek decyduje</a:t>
+              <a:t>HITL dla P-014 (CRM Helios): AI proponuje, konsultant kwalifikuje</a:t>
             </a:r>
           </a:p>
         </p:txBody>
@@ -9145,7 +9145,7 @@
                 </a:solidFill>
                 <a:latin typeface="Calibri"/>
               </a:rPr>
-              <a:t>rozpoznaje temat, klienta i zamówienie; dzieli e-mail z kilkoma pytaniami</a:t>
+              <a:t>rozpoznaje klienta i zamówienie, tworzy kartę reklamacji i listę braków</a:t>
             </a:r>
           </a:p>
         </p:txBody>
@@ -9281,7 +9281,7 @@
                 </a:solidFill>
                 <a:latin typeface="Calibri"/>
               </a:rPr>
-              <a:t>pisze szkic z historii kontaktów i bazy gotowych odpowiedzi</a:t>
+              <a:t>proponuje kategorię i priorytet SLA z pewnością; &lt; 80% → konsultant ręcznie</a:t>
             </a:r>
           </a:p>
         </p:txBody>
@@ -9417,7 +9417,7 @@
                 </a:solidFill>
                 <a:latin typeface="Calibri"/>
               </a:rPr>
-              <a:t>zatwierdza lub poprawia — wysyłka zawsze po decyzji człowieka</a:t>
+              <a:t>zatwierdza lub zmienia kategorię i priorytet — punkt kontroli</a:t>
             </a:r>
           </a:p>
         </p:txBody>
@@ -9541,7 +9541,7 @@
                 </a:solidFill>
                 <a:latin typeface="Calibri"/>
               </a:rPr>
-              <a:t>Eskalacja → lider</a:t>
+              <a:t>Eskalacja → specjalista</a:t>
             </a:r>
           </a:p>
           <a:p>
@@ -9553,7 +9553,7 @@
                 </a:solidFill>
                 <a:latin typeface="Calibri"/>
               </a:rPr>
-              <a:t>skarga, reklamacja, roszczenie, groźba prawna, dane osobowe, prośba o wyjątek</a:t>
+              <a:t>bezpieczeństwo produktu, wysoka wartość, spór, brak dowodu → P-015</a:t>
             </a:r>
           </a:p>
         </p:txBody>
@@ -9582,31 +9582,52 @@
           <a:p>
             <a:pPr algn="l"/>
             <a:r>
-              <a:rPr sz="1100" b="1" i="0">
+              <a:rPr sz="1050" b="1" i="0">
                 <a:solidFill>
                   <a:srgbClr val="1C2430"/>
                 </a:solidFill>
                 <a:latin typeface="Calibri"/>
               </a:rPr>
+              <a:t>Kontrola: </a:t>
+            </a:r>
+            <a:r>
+              <a:rPr sz="1050" b="0" i="0">
+                <a:solidFill>
+                  <a:srgbClr val="1C2430"/>
+                </a:solidFill>
+                <a:latin typeface="Calibri"/>
+              </a:rPr>
+              <a:t>10% próbki tygodniowo; trafność &lt; 90% → AI wstrzymane. Efekt: czas −30%, błędy 6,9% → &lt; 4%</a:t>
+            </a:r>
+          </a:p>
+          <a:p>
+            <a:pPr algn="l"/>
+            <a:r>
+              <a:rPr sz="1050" b="1" i="0">
+                <a:solidFill>
+                  <a:srgbClr val="1C2430"/>
+                </a:solidFill>
+                <a:latin typeface="Calibri"/>
+              </a:rPr>
               <a:t>Koszt technologii rok 1: </a:t>
             </a:r>
             <a:r>
-              <a:rPr sz="1100" b="0" i="0">
+              <a:rPr sz="1050" b="0" i="0">
                 <a:solidFill>
                   <a:srgbClr val="1C2430"/>
                 </a:solidFill>
                 <a:latin typeface="Calibri"/>
               </a:rPr>
-              <a:t>ok. 295 tys. zł z limitu 300 tys. zł </a:t>
-            </a:r>
-            <a:r>
-              <a:rPr sz="1000" b="0" i="0">
+              <a:t>ok. 222 tys. zł z 300 tys. zł </a:t>
+            </a:r>
+            <a:r>
+              <a:rPr sz="950" b="0" i="0">
                 <a:solidFill>
                   <a:srgbClr val="5B6775"/>
                 </a:solidFill>
                 <a:latin typeface="Calibri"/>
               </a:rPr>
-              <a:t>(3D: Operacje 111 tys. · Hybryda 150 tys. · Asystent 33 tys.)</a:t>
+              <a:t>(Hybryda P-014 68 · Asystent P-012 72 · Hybryda P-001 82 tys.)</a:t>
             </a:r>
           </a:p>
         </p:txBody>
@@ -9775,7 +9796,7 @@
                 </a:solidFill>
                 <a:latin typeface="Calibri"/>
               </a:rPr>
-              <a:t>ok. 45 etatów-ekw.</a:t>
+              <a:t>ok. 36 etatów</a:t>
             </a:r>
           </a:p>
           <a:p>
@@ -9787,7 +9808,7 @@
                 </a:solidFill>
                 <a:latin typeface="Calibri"/>
               </a:rPr>
-              <a:t>uwolnionego czasu miesięcznie (hipoteza*)</a:t>
+              <a:t>zdolności miesięcznie (5 789 h/m, hipoteza zespołu*)</a:t>
             </a:r>
           </a:p>
         </p:txBody>
@@ -9831,7 +9852,7 @@
                 </a:solidFill>
                 <a:latin typeface="Calibri"/>
               </a:rPr>
-              <a:t>stabilizacja SLA w szczytach NORDY · S-01 Kastella (6,5 et.) · projekty kierunku (8,6 et.)</a:t>
+              <a:t>szczyty XI–XII i SLA NORDY · S-01 Kastella (6,5 et.) · projekty kierunku (8,6 et.)</a:t>
             </a:r>
           </a:p>
         </p:txBody>
@@ -9875,7 +9896,7 @@
                 </a:solidFill>
                 <a:latin typeface="Calibri"/>
               </a:rPr>
-              <a:t>dopasowanie przez naturalną rotację i wstrzymanie rekrutacji</a:t>
+              <a:t>„odciążenie, nie redukcja” przed pilotażem, gwarancja ról; resztę dopasowuje rotacja</a:t>
             </a:r>
           </a:p>
         </p:txBody>
@@ -9919,7 +9940,7 @@
                 </a:solidFill>
                 <a:latin typeface="Calibri"/>
               </a:rPr>
-              <a:t>Obsługa Klienta: 9% → [cel] · Finanse: 17% → [cel] · IT jako ambasadorzy (73%)</a:t>
+              <a:t>praca z AI przed startem: OK 9% → [cel] · Finanse 17% → [cel] · liderzy zmian z OK</a:t>
             </a:r>
           </a:p>
         </p:txBody>
@@ -9954,7 +9975,7 @@
                 </a:solidFill>
                 <a:latin typeface="Calibri"/>
               </a:rPr>
-              <a:t>Komunikacja: </a:t>
+              <a:t>Ryzyko nr 1: </a:t>
             </a:r>
             <a:r>
               <a:rPr sz="1050" b="0" i="0">
@@ -9963,7 +9984,7 @@
                 </a:solidFill>
                 <a:latin typeface="Calibri"/>
               </a:rPr>
-              <a:t>polityka AI i jasne role — dziś 6,8% widzi jasną komunikację (Q21)</a:t>
+              <a:t>lęk o pracę: 82% w OK boi się o stanowisko; lęk najsilniej przewiduje odejście (r = −0,68)</a:t>
             </a:r>
           </a:p>
         </p:txBody>
@@ -10007,7 +10028,7 @@
                 </a:solidFill>
                 <a:latin typeface="Calibri"/>
               </a:rPr>
-              <a:t>SLA OK 92,1% → [cel] · kary −[x]% · rotacja OK 24,5% → [cel]</a:t>
+              <a:t>SLA OK 92,1% → [cel] · błędy reklamacji 6,9% → &lt; 4% · rotacja OK 24,5% → [cel]</a:t>
             </a:r>
           </a:p>
         </p:txBody>
@@ -10086,7 +10107,7 @@
                 </a:solidFill>
                 <a:latin typeface="Calibri"/>
               </a:rPr>
-              <a:t>* Hipoteza skrócenia czasu [ZAŁOŻENIE]: P-001 −60%, P-012 −40%, P-039 −30% godzin z 3A; 1 etat = 160 h/m. Źródła: Etap 3 — 3A (wolumeny, godziny), 3D (cennik), karty procesów DOCX; ankieta Q16, Q21, Q26.</a:t>
+              <a:t>* Hipoteza zespołu (3B, kol. H): P-014 −30%, P-012 −30%, P-001 −50% godzin z 3A; 1 etat = 160 h/m. Źródła: Etap 3 — 3B (wybór, licencje, rok 1), 3C (mapa HITL P-014), 3D (cennik); ankieta Q14, Q20, Q26.</a:t>
             </a:r>
           </a:p>
         </p:txBody>

</xml_diff>

<commit_message>
E4: slajd 3 z rokiem zmiany (3 fazy, bramy, 3 KPI), skrypt z notatek, decyzje-E4 i rejestr
Co-Authored-By: Claude Opus 5.5 <noreply@anthropic.com>
Claude-Session: https://claude.ai/code/session_01G5YqtdXDgytrewF8H77h4S
</commit_message>
<xml_diff>
--- a/05_etap5_prezentacja/slajdy/HELVIA_deck_v1.pptx
+++ b/05_etap5_prezentacja/slajdy/HELVIA_deck_v1.pptx
@@ -668,13 +668,13 @@
           <a:lstStyle/>
           <a:p>
             <a:r>
-              <a:t>[1:50–2:40 · Analityk ludzi i ryzyk] Nasza zasada brzmi: AI przygotowuje, człowiek decyduje. Wdrażamy ją tam, gdzie powstają kary — w Obsłudze Klienta, gdzie NORDA i Lumea odpowiadają za 94% kar SLA. Przy rejestracji reklamacji AI rozpoznaje klienta, przygotowuje kartę i proponuje kategorię oraz priorytet, ale każdą kwalifikację zatwierdza konsultant. Gdy AI nie jest pewne na 80%, sprawę od razu przejmuje człowiek. Bezpieczeństwo produktu, wysoka wartość i spory trafiają do specjalisty. Co tydzień sprawdzamy 10% spraw, a gdy trafność spada poniżej 90%, wyłączamy propozycje AI. Przy e-mailach AI pisze szkic, a wysyła człowiek. Faktury rejestruje automat, a wyjątki obsługują księgowi. Decyzje reklamacyjne świadomie zostawiamy ludziom. Koszt technologii to ok. 222 tys. zł z 300 tys. zł limitu.</a:t>
+              <a:t>[1:50–2:40 · Analityk ludzi i ryzyk] Nasza zasada: AI przygotowuje, człowiek decyduje. Wdrażamy ją tam, gdzie powstają kary. Przy reklamacjach AI proponuje kategorię i priorytet, a zatwierdza konsultant. Gdy AI nie jest pewne na 80%, sprawę od razu przejmuje człowiek. E-mail pisze AI, a podpisuje człowiek. Faktury rejestruje automat, a wyjątki obsługują księgowi. Decyzje reklamacyjne zostają u ludzi. Koszt: 222 tys. zł z 300 tys. limitu.</a:t>
             </a:r>
           </a:p>
           <a:p/>
           <a:p>
             <a:r>
-              <a:t>Uwalniamy ok. 36 etatów zdolności i nie oznacza to zwolnień. Ten czas idzie na szczyty NORDY i projekt dla Kastelli. Zanim ruszy pilotaż, mówimy wprost: „odciążenie, nie redukcja”. Robimy tak, bo 82% konsultantów boi się o pracę, a ten lęk najmocniej przewiduje odejścia.</a:t>
+              <a:t>Zmiana obejmuje 96 etatów, a większość konsultantów boi się o pracę. Dlatego zaczynamy od ludzi: gwarancja, że przez rok nikt nie straci pracy z powodu AI, i jasne zasady. Potem pilotaż z ochotnikami z zespołu NORDY. Rozszerzamy dopiero, gdy trafność AI przekracza 90%, a SLA nie spada. Uwolniony czas idzie na szczyty NORDY i projekt dla Kastelli, a trzy nowe role obsadzamy z wewnątrz. Po roku: SLA NORDY 95%, 80% aktywnych kont AI i mniej lęku o pracę.</a:t>
             </a:r>
           </a:p>
           <a:p/>
@@ -686,7 +686,17 @@
           <a:p/>
           <a:p>
             <a:r>
-              <a:t>[DECYZJA ZESPOŁU — 3B/3C] P-014 (HITL, mapa 3C), P-012 (HITL, Asystent), P-001 (automatyzacja), P-015 zostaje u człowieka; hipotezy −30/−30/−50%. [DO WERYFIKACJI] 36 etatów to zdolność z hipotezy, a nie zmierzony efekt — w E4 rozpiszcie, ile idzie na szczyty i SLA, ile na S-01 (6,5 et.) i projekty kierunku (8,6 et.), a ile wchłonie rotacja. [ZAŁOŻENIE] Koszt nie obejmuje szkoleń ani czasu nadzoru (3B A41).</a:t>
+              <a:t>[DECYZJA ZESPOŁU — 3B/3C, 4A–4C] Procesy P-014, P-012, P-001 + P-015 u człowieka; fazy i bramy z 4B; KPI z 4C; gwarancja 0 zwolnień z powodu AI przez 12 mies. (4B C12).</a:t>
+            </a:r>
+          </a:p>
+          <a:p>
+            <a:r>
+              <a:t>[DO WERYFIKACJI] 36 etatów liczono na godzinach z arkusza 3A z pliku Etapu 3 (P-001 5 924 h, P-012 7 062 h, P-014 2 362 h). W pliku Etapu 4 arkusz 3A liczy godziny z „Wolumeny klient proces” i daje 1 656,5 / 4 470,1 / 1 494,9 h → przy tych samych hipotezach 2 617,8 h = 16,4 etatu. Potwierdźcie z mentorem, który 3A obowiązuje.</a:t>
+            </a:r>
+          </a:p>
+          <a:p>
+            <a:r>
+              <a:t>[PYTANIE JURY] 4A G19: decyzja o nieobsadzaniu wakatów z rotacji (ok. 50 odejść/rok w OK) zapada po mies. 6 — przygotujcie odpowiedź, czy to „redukcja przez rotację”.</a:t>
             </a:r>
           </a:p>
         </p:txBody>
@@ -8007,7 +8017,7 @@
                 </a:solidFill>
                 <a:latin typeface="Calibri"/>
               </a:rPr>
-              <a:t>AI przygotowuje, człowiek decyduje: 3 procesy z AI, reklamacje złożone zostają u ludzi — 36 etatów zdolności idzie w SLA i wzrost, nie w zwolnienia</a:t>
+              <a:t>AI przygotowuje, człowiek decyduje — przez rok zero zwolnień z powodu AI, a 36 etatów zdolności idzie w SLA i wzrost</a:t>
             </a:r>
           </a:p>
         </p:txBody>
@@ -9684,8 +9694,8 @@
         </p:nvSpPr>
         <p:spPr>
           <a:xfrm>
-            <a:off x="7315200" y="1783080"/>
-            <a:ext cx="4297680" cy="274320"/>
+            <a:off x="7315200" y="1764792"/>
+            <a:ext cx="2743200" cy="274320"/>
           </a:xfrm>
           <a:prstGeom prst="rect">
             <a:avLst/>
@@ -9706,7 +9716,7 @@
                 </a:solidFill>
                 <a:latin typeface="Calibri"/>
               </a:rPr>
-              <a:t>A co z ludźmi? (Etap 4)</a:t>
+              <a:t>A co z ludźmi? Rok zmiany</a:t>
             </a:r>
           </a:p>
         </p:txBody>
@@ -9719,8 +9729,8 @@
         </p:nvSpPr>
         <p:spPr>
           <a:xfrm>
-            <a:off x="10012680" y="1801368"/>
-            <a:ext cx="1554480" cy="256032"/>
+            <a:off x="9710928" y="1792224"/>
+            <a:ext cx="1856231" cy="256032"/>
           </a:xfrm>
           <a:prstGeom prst="roundRect">
             <a:avLst/>
@@ -9761,7 +9771,7 @@
                 </a:solidFill>
                 <a:latin typeface="Calibri"/>
               </a:rPr>
-              <a:t>UZUPEŁNIĆ W E4</a:t>
+              <a:t>0 ZWOLNIEŃ Z POWODU AI</a:t>
             </a:r>
           </a:p>
         </p:txBody>
@@ -9774,8 +9784,8 @@
         </p:nvSpPr>
         <p:spPr>
           <a:xfrm>
-            <a:off x="7315200" y="2194560"/>
-            <a:ext cx="4297680" cy="822960"/>
+            <a:off x="7315200" y="2103120"/>
+            <a:ext cx="4297680" cy="457200"/>
           </a:xfrm>
           <a:prstGeom prst="rect">
             <a:avLst/>
@@ -9790,39 +9800,414 @@
           <a:p>
             <a:pPr algn="l"/>
             <a:r>
-              <a:rPr sz="2600" b="1" i="0">
-                <a:solidFill>
-                  <a:srgbClr val="0F7C7E"/>
-                </a:solidFill>
-                <a:latin typeface="Calibri"/>
-              </a:rPr>
-              <a:t>ok. 36 etatów</a:t>
-            </a:r>
-          </a:p>
+              <a:rPr sz="1050" b="1" i="0">
+                <a:solidFill>
+                  <a:srgbClr val="1C2430"/>
+                </a:solidFill>
+                <a:latin typeface="Calibri"/>
+              </a:rPr>
+              <a:t>96 etatów objętych zmianą (13% firmy). </a:t>
+            </a:r>
+            <a:r>
+              <a:rPr sz="1050" b="0" i="0">
+                <a:solidFill>
+                  <a:srgbClr val="1C2430"/>
+                </a:solidFill>
+                <a:latin typeface="Calibri"/>
+              </a:rPr>
+              <a:t>36 etatów zdolności* → szczyty NORDY, SLA, S-01 Kastella (6,5 et.)</a:t>
+            </a:r>
+          </a:p>
+        </p:txBody>
+      </p:sp>
+      <p:sp>
+        <p:nvSpPr>
+          <p:cNvPr id="49" name="Rectangle 48"/>
+          <p:cNvSpPr/>
+          <p:nvPr/>
+        </p:nvSpPr>
+        <p:spPr>
+          <a:xfrm>
+            <a:off x="7315200" y="2606040"/>
+            <a:ext cx="868680" cy="530352"/>
+          </a:xfrm>
+          <a:prstGeom prst="rect">
+            <a:avLst/>
+          </a:prstGeom>
+          <a:solidFill>
+            <a:srgbClr val="1F3A5F"/>
+          </a:solidFill>
+          <a:ln>
+            <a:noFill/>
+          </a:ln>
+          <a:effectLst/>
+        </p:spPr>
+        <p:style>
+          <a:lnRef idx="1">
+            <a:schemeClr val="accent1"/>
+          </a:lnRef>
+          <a:fillRef idx="3">
+            <a:schemeClr val="accent1"/>
+          </a:fillRef>
+          <a:effectRef idx="2">
+            <a:schemeClr val="accent1"/>
+          </a:effectRef>
+          <a:fontRef idx="minor">
+            <a:schemeClr val="lt1"/>
+          </a:fontRef>
+        </p:style>
+        <p:txBody>
+          <a:bodyPr rtlCol="0" anchor="ctr"/>
+          <a:lstStyle/>
+          <a:p>
+            <a:pPr algn="ctr"/>
+          </a:p>
+        </p:txBody>
+      </p:sp>
+      <p:sp>
+        <p:nvSpPr>
+          <p:cNvPr id="50" name="TextBox 49"/>
+          <p:cNvSpPr txBox="1"/>
+          <p:nvPr/>
+        </p:nvSpPr>
+        <p:spPr>
+          <a:xfrm>
+            <a:off x="7315200" y="2606040"/>
+            <a:ext cx="868680" cy="530352"/>
+          </a:xfrm>
+          <a:prstGeom prst="rect">
+            <a:avLst/>
+          </a:prstGeom>
+          <a:noFill/>
+        </p:spPr>
+        <p:txBody>
+          <a:bodyPr wrap="square" anchor="ctr" lIns="73152" rIns="73152" tIns="36576" bIns="36576">
+            <a:spAutoFit/>
+          </a:bodyPr>
+          <a:lstStyle/>
+          <a:p>
+            <a:pPr algn="ctr"/>
+            <a:r>
+              <a:rPr sz="950" b="1" i="0">
+                <a:solidFill>
+                  <a:srgbClr val="FFFFFF"/>
+                </a:solidFill>
+                <a:latin typeface="Calibri"/>
+              </a:rPr>
+              <a:t>MIES. 1–3</a:t>
+            </a:r>
+          </a:p>
+        </p:txBody>
+      </p:sp>
+      <p:sp>
+        <p:nvSpPr>
+          <p:cNvPr id="51" name="TextBox 50"/>
+          <p:cNvSpPr txBox="1"/>
+          <p:nvPr/>
+        </p:nvSpPr>
+        <p:spPr>
+          <a:xfrm>
+            <a:off x="8229600" y="2587752"/>
+            <a:ext cx="3383280" cy="566928"/>
+          </a:xfrm>
+          <a:prstGeom prst="rect">
+            <a:avLst/>
+          </a:prstGeom>
+          <a:noFill/>
+        </p:spPr>
+        <p:txBody>
+          <a:bodyPr wrap="square" anchor="ctr" lIns="73152" rIns="73152" tIns="36576" bIns="36576">
+            <a:spAutoFit/>
+          </a:bodyPr>
+          <a:lstStyle/>
           <a:p>
             <a:pPr algn="l"/>
             <a:r>
-              <a:rPr sz="1100" b="0" i="0">
+              <a:rPr sz="950" b="0" i="0">
+                <a:solidFill>
+                  <a:srgbClr val="1C2430"/>
+                </a:solidFill>
+                <a:latin typeface="Calibri"/>
+              </a:rPr>
+              <a:t>Gwarancja i polityka AI, rozmowy 1:1 · pilotaż P-014/P-012 z ochotnikami NORDY</a:t>
+            </a:r>
+          </a:p>
+          <a:p>
+            <a:pPr algn="l"/>
+            <a:r>
+              <a:rPr sz="850" b="0" i="1">
                 <a:solidFill>
                   <a:srgbClr val="5B6775"/>
                 </a:solidFill>
                 <a:latin typeface="Calibri"/>
               </a:rPr>
-              <a:t>zdolności miesięcznie (5 789 h/m, hipoteza zespołu*)</a:t>
-            </a:r>
-          </a:p>
-        </p:txBody>
-      </p:sp>
-      <p:sp>
-        <p:nvSpPr>
-          <p:cNvPr id="49" name="TextBox 48"/>
+              <a:t>Brama: trafność AI ≥ 90%, SLA NORDY nie spada</a:t>
+            </a:r>
+          </a:p>
+        </p:txBody>
+      </p:sp>
+      <p:sp>
+        <p:nvSpPr>
+          <p:cNvPr id="52" name="Rectangle 51"/>
+          <p:cNvSpPr/>
+          <p:nvPr/>
+        </p:nvSpPr>
+        <p:spPr>
+          <a:xfrm>
+            <a:off x="7315200" y="3200400"/>
+            <a:ext cx="868680" cy="530352"/>
+          </a:xfrm>
+          <a:prstGeom prst="rect">
+            <a:avLst/>
+          </a:prstGeom>
+          <a:solidFill>
+            <a:srgbClr val="0F7C7E"/>
+          </a:solidFill>
+          <a:ln>
+            <a:noFill/>
+          </a:ln>
+          <a:effectLst/>
+        </p:spPr>
+        <p:style>
+          <a:lnRef idx="1">
+            <a:schemeClr val="accent1"/>
+          </a:lnRef>
+          <a:fillRef idx="3">
+            <a:schemeClr val="accent1"/>
+          </a:fillRef>
+          <a:effectRef idx="2">
+            <a:schemeClr val="accent1"/>
+          </a:effectRef>
+          <a:fontRef idx="minor">
+            <a:schemeClr val="lt1"/>
+          </a:fontRef>
+        </p:style>
+        <p:txBody>
+          <a:bodyPr rtlCol="0" anchor="ctr"/>
+          <a:lstStyle/>
+          <a:p>
+            <a:pPr algn="ctr"/>
+          </a:p>
+        </p:txBody>
+      </p:sp>
+      <p:sp>
+        <p:nvSpPr>
+          <p:cNvPr id="53" name="TextBox 52"/>
           <p:cNvSpPr txBox="1"/>
           <p:nvPr/>
         </p:nvSpPr>
         <p:spPr>
           <a:xfrm>
-            <a:off x="7315200" y="3127248"/>
-            <a:ext cx="4297680" cy="566928"/>
+            <a:off x="7315200" y="3200400"/>
+            <a:ext cx="868680" cy="530352"/>
+          </a:xfrm>
+          <a:prstGeom prst="rect">
+            <a:avLst/>
+          </a:prstGeom>
+          <a:noFill/>
+        </p:spPr>
+        <p:txBody>
+          <a:bodyPr wrap="square" anchor="ctr" lIns="73152" rIns="73152" tIns="36576" bIns="36576">
+            <a:spAutoFit/>
+          </a:bodyPr>
+          <a:lstStyle/>
+          <a:p>
+            <a:pPr algn="ctr"/>
+            <a:r>
+              <a:rPr sz="950" b="1" i="0">
+                <a:solidFill>
+                  <a:srgbClr val="FFFFFF"/>
+                </a:solidFill>
+                <a:latin typeface="Calibri"/>
+              </a:rPr>
+              <a:t>MIES. 4–6</a:t>
+            </a:r>
+          </a:p>
+        </p:txBody>
+      </p:sp>
+      <p:sp>
+        <p:nvSpPr>
+          <p:cNvPr id="54" name="TextBox 53"/>
+          <p:cNvSpPr txBox="1"/>
+          <p:nvPr/>
+        </p:nvSpPr>
+        <p:spPr>
+          <a:xfrm>
+            <a:off x="8229600" y="3182112"/>
+            <a:ext cx="3383280" cy="566928"/>
+          </a:xfrm>
+          <a:prstGeom prst="rect">
+            <a:avLst/>
+          </a:prstGeom>
+          <a:noFill/>
+        </p:spPr>
+        <p:txBody>
+          <a:bodyPr wrap="square" anchor="ctr" lIns="73152" rIns="73152" tIns="36576" bIns="36576">
+            <a:spAutoFit/>
+          </a:bodyPr>
+          <a:lstStyle/>
+          <a:p>
+            <a:pPr algn="l"/>
+            <a:r>
+              <a:rPr sz="950" b="0" i="0">
+                <a:solidFill>
+                  <a:srgbClr val="1C2430"/>
+                </a:solidFill>
+                <a:latin typeface="Calibri"/>
+              </a:rPr>
+              <a:t>Cała Obsługa Klienta (55 kont) · automat faktur P-001</a:t>
+            </a:r>
+          </a:p>
+          <a:p>
+            <a:pPr algn="l"/>
+            <a:r>
+              <a:rPr sz="850" b="0" i="1">
+                <a:solidFill>
+                  <a:srgbClr val="5B6775"/>
+                </a:solidFill>
+                <a:latin typeface="Calibri"/>
+              </a:rPr>
+              <a:t>Brama: SLA NORDY ≥ 93%, ≥ 75% faktur automatycznie</a:t>
+            </a:r>
+          </a:p>
+        </p:txBody>
+      </p:sp>
+      <p:sp>
+        <p:nvSpPr>
+          <p:cNvPr id="55" name="Rectangle 54"/>
+          <p:cNvSpPr/>
+          <p:nvPr/>
+        </p:nvSpPr>
+        <p:spPr>
+          <a:xfrm>
+            <a:off x="7315200" y="3794760"/>
+            <a:ext cx="868680" cy="530352"/>
+          </a:xfrm>
+          <a:prstGeom prst="rect">
+            <a:avLst/>
+          </a:prstGeom>
+          <a:solidFill>
+            <a:srgbClr val="C77C0E"/>
+          </a:solidFill>
+          <a:ln>
+            <a:noFill/>
+          </a:ln>
+          <a:effectLst/>
+        </p:spPr>
+        <p:style>
+          <a:lnRef idx="1">
+            <a:schemeClr val="accent1"/>
+          </a:lnRef>
+          <a:fillRef idx="3">
+            <a:schemeClr val="accent1"/>
+          </a:fillRef>
+          <a:effectRef idx="2">
+            <a:schemeClr val="accent1"/>
+          </a:effectRef>
+          <a:fontRef idx="minor">
+            <a:schemeClr val="lt1"/>
+          </a:fontRef>
+        </p:style>
+        <p:txBody>
+          <a:bodyPr rtlCol="0" anchor="ctr"/>
+          <a:lstStyle/>
+          <a:p>
+            <a:pPr algn="ctr"/>
+          </a:p>
+        </p:txBody>
+      </p:sp>
+      <p:sp>
+        <p:nvSpPr>
+          <p:cNvPr id="56" name="TextBox 55"/>
+          <p:cNvSpPr txBox="1"/>
+          <p:nvPr/>
+        </p:nvSpPr>
+        <p:spPr>
+          <a:xfrm>
+            <a:off x="7315200" y="3794760"/>
+            <a:ext cx="868680" cy="530352"/>
+          </a:xfrm>
+          <a:prstGeom prst="rect">
+            <a:avLst/>
+          </a:prstGeom>
+          <a:noFill/>
+        </p:spPr>
+        <p:txBody>
+          <a:bodyPr wrap="square" anchor="ctr" lIns="73152" rIns="73152" tIns="36576" bIns="36576">
+            <a:spAutoFit/>
+          </a:bodyPr>
+          <a:lstStyle/>
+          <a:p>
+            <a:pPr algn="ctr"/>
+            <a:r>
+              <a:rPr sz="950" b="1" i="0">
+                <a:solidFill>
+                  <a:srgbClr val="FFFFFF"/>
+                </a:solidFill>
+                <a:latin typeface="Calibri"/>
+              </a:rPr>
+              <a:t>MIES. 7–12</a:t>
+            </a:r>
+          </a:p>
+        </p:txBody>
+      </p:sp>
+      <p:sp>
+        <p:nvSpPr>
+          <p:cNvPr id="57" name="TextBox 56"/>
+          <p:cNvSpPr txBox="1"/>
+          <p:nvPr/>
+        </p:nvSpPr>
+        <p:spPr>
+          <a:xfrm>
+            <a:off x="8229600" y="3776472"/>
+            <a:ext cx="3383280" cy="566928"/>
+          </a:xfrm>
+          <a:prstGeom prst="rect">
+            <a:avLst/>
+          </a:prstGeom>
+          <a:noFill/>
+        </p:spPr>
+        <p:txBody>
+          <a:bodyPr wrap="square" anchor="ctr" lIns="73152" rIns="73152" tIns="36576" bIns="36576">
+            <a:spAutoFit/>
+          </a:bodyPr>
+          <a:lstStyle/>
+          <a:p>
+            <a:pPr algn="l"/>
+            <a:r>
+              <a:rPr sz="950" b="0" i="0">
+                <a:solidFill>
+                  <a:srgbClr val="1C2430"/>
+                </a:solidFill>
+                <a:latin typeface="Calibri"/>
+              </a:rPr>
+              <a:t>Czas → S-01 i szczyty XI–XII · 3 nowe role z wewnątrz · 2. fala AI</a:t>
+            </a:r>
+          </a:p>
+          <a:p>
+            <a:pPr algn="l"/>
+            <a:r>
+              <a:rPr sz="850" b="0" i="1">
+                <a:solidFill>
+                  <a:srgbClr val="5B6775"/>
+                </a:solidFill>
+                <a:latin typeface="Calibri"/>
+              </a:rPr>
+              <a:t>Brama: 0 zwolnień, SLA Finansów ≥ 96,2%</a:t>
+            </a:r>
+          </a:p>
+        </p:txBody>
+      </p:sp>
+      <p:sp>
+        <p:nvSpPr>
+          <p:cNvPr id="58" name="TextBox 57"/>
+          <p:cNvSpPr txBox="1"/>
+          <p:nvPr/>
+        </p:nvSpPr>
+        <p:spPr>
+          <a:xfrm>
+            <a:off x="7315200" y="4416552"/>
+            <a:ext cx="4297680" cy="274320"/>
           </a:xfrm>
           <a:prstGeom prst="rect">
             <a:avLst/>
@@ -9837,36 +10222,71 @@
           <a:p>
             <a:pPr algn="l"/>
             <a:r>
-              <a:rPr sz="1100" b="1" i="0">
-                <a:solidFill>
-                  <a:srgbClr val="1C2430"/>
-                </a:solidFill>
-                <a:latin typeface="Calibri"/>
-              </a:rPr>
-              <a:t>Gdzie trafia czas: </a:t>
-            </a:r>
-            <a:r>
-              <a:rPr sz="1050" b="0" i="0">
-                <a:solidFill>
-                  <a:srgbClr val="1C2430"/>
-                </a:solidFill>
-                <a:latin typeface="Calibri"/>
-              </a:rPr>
-              <a:t>szczyty XI–XII i SLA NORDY · S-01 Kastella (6,5 et.) · projekty kierunku (8,6 et.)</a:t>
-            </a:r>
-          </a:p>
-        </p:txBody>
-      </p:sp>
-      <p:sp>
-        <p:nvSpPr>
-          <p:cNvPr id="50" name="TextBox 49"/>
+              <a:rPr sz="1150" b="1" i="0">
+                <a:solidFill>
+                  <a:srgbClr val="1F3A5F"/>
+                </a:solidFill>
+                <a:latin typeface="Calibri"/>
+              </a:rPr>
+              <a:t>3 rezultaty po 12 miesiącach (4C)</a:t>
+            </a:r>
+          </a:p>
+        </p:txBody>
+      </p:sp>
+      <p:sp>
+        <p:nvSpPr>
+          <p:cNvPr id="59" name="Rectangle 58"/>
+          <p:cNvSpPr/>
+          <p:nvPr/>
+        </p:nvSpPr>
+        <p:spPr>
+          <a:xfrm>
+            <a:off x="7315200" y="4709160"/>
+            <a:ext cx="4297680" cy="274320"/>
+          </a:xfrm>
+          <a:prstGeom prst="rect">
+            <a:avLst/>
+          </a:prstGeom>
+          <a:solidFill>
+            <a:srgbClr val="1F3A5F"/>
+          </a:solidFill>
+          <a:ln>
+            <a:noFill/>
+          </a:ln>
+          <a:effectLst/>
+        </p:spPr>
+        <p:style>
+          <a:lnRef idx="1">
+            <a:schemeClr val="accent1"/>
+          </a:lnRef>
+          <a:fillRef idx="3">
+            <a:schemeClr val="accent1"/>
+          </a:fillRef>
+          <a:effectRef idx="2">
+            <a:schemeClr val="accent1"/>
+          </a:effectRef>
+          <a:fontRef idx="minor">
+            <a:schemeClr val="lt1"/>
+          </a:fontRef>
+        </p:style>
+        <p:txBody>
+          <a:bodyPr rtlCol="0" anchor="ctr"/>
+          <a:lstStyle/>
+          <a:p>
+            <a:pPr algn="ctr"/>
+          </a:p>
+        </p:txBody>
+      </p:sp>
+      <p:sp>
+        <p:nvSpPr>
+          <p:cNvPr id="60" name="TextBox 59"/>
           <p:cNvSpPr txBox="1"/>
           <p:nvPr/>
         </p:nvSpPr>
         <p:spPr>
           <a:xfrm>
-            <a:off x="7315200" y="3730752"/>
-            <a:ext cx="4297680" cy="566928"/>
+            <a:off x="7315200" y="4709160"/>
+            <a:ext cx="2148840" cy="274320"/>
           </a:xfrm>
           <a:prstGeom prst="rect">
             <a:avLst/>
@@ -9874,43 +10294,34 @@
           <a:noFill/>
         </p:spPr>
         <p:txBody>
-          <a:bodyPr wrap="square" anchor="t" lIns="73152" rIns="73152" tIns="36576" bIns="36576">
+          <a:bodyPr wrap="square" anchor="ctr" lIns="73152" rIns="73152" tIns="36576" bIns="36576">
             <a:spAutoFit/>
           </a:bodyPr>
           <a:lstStyle/>
           <a:p>
             <a:pPr algn="l"/>
             <a:r>
-              <a:rPr sz="1100" b="1" i="0">
-                <a:solidFill>
-                  <a:srgbClr val="1C2430"/>
-                </a:solidFill>
-                <a:latin typeface="Calibri"/>
-              </a:rPr>
-              <a:t>Zero zwolnień: </a:t>
-            </a:r>
-            <a:r>
-              <a:rPr sz="1050" b="0" i="0">
-                <a:solidFill>
-                  <a:srgbClr val="1C2430"/>
-                </a:solidFill>
-                <a:latin typeface="Calibri"/>
-              </a:rPr>
-              <a:t>„odciążenie, nie redukcja” przed pilotażem, gwarancja ról; resztę dopasowuje rotacja</a:t>
-            </a:r>
-          </a:p>
-        </p:txBody>
-      </p:sp>
-      <p:sp>
-        <p:nvSpPr>
-          <p:cNvPr id="51" name="TextBox 50"/>
+              <a:rPr sz="900" b="1" i="0">
+                <a:solidFill>
+                  <a:srgbClr val="FFFFFF"/>
+                </a:solidFill>
+                <a:latin typeface="Calibri"/>
+              </a:rPr>
+              <a:t>Rezultat</a:t>
+            </a:r>
+          </a:p>
+        </p:txBody>
+      </p:sp>
+      <p:sp>
+        <p:nvSpPr>
+          <p:cNvPr id="61" name="TextBox 60"/>
           <p:cNvSpPr txBox="1"/>
           <p:nvPr/>
         </p:nvSpPr>
         <p:spPr>
           <a:xfrm>
-            <a:off x="7315200" y="4334256"/>
-            <a:ext cx="4297680" cy="566928"/>
+            <a:off x="9464040" y="4709160"/>
+            <a:ext cx="1097280" cy="274320"/>
           </a:xfrm>
           <a:prstGeom prst="rect">
             <a:avLst/>
@@ -9918,43 +10329,34 @@
           <a:noFill/>
         </p:spPr>
         <p:txBody>
-          <a:bodyPr wrap="square" anchor="t" lIns="73152" rIns="73152" tIns="36576" bIns="36576">
+          <a:bodyPr wrap="square" anchor="ctr" lIns="73152" rIns="73152" tIns="36576" bIns="36576">
             <a:spAutoFit/>
           </a:bodyPr>
           <a:lstStyle/>
           <a:p>
             <a:pPr algn="l"/>
             <a:r>
-              <a:rPr sz="1100" b="1" i="0">
-                <a:solidFill>
-                  <a:srgbClr val="1C2430"/>
-                </a:solidFill>
-                <a:latin typeface="Calibri"/>
-              </a:rPr>
-              <a:t>Szkolenia: </a:t>
-            </a:r>
-            <a:r>
-              <a:rPr sz="1050" b="0" i="0">
-                <a:solidFill>
-                  <a:srgbClr val="1C2430"/>
-                </a:solidFill>
-                <a:latin typeface="Calibri"/>
-              </a:rPr>
-              <a:t>praca z AI przed startem: OK 9% → [cel] · Finanse 17% → [cel] · liderzy zmian z OK</a:t>
-            </a:r>
-          </a:p>
-        </p:txBody>
-      </p:sp>
-      <p:sp>
-        <p:nvSpPr>
-          <p:cNvPr id="52" name="TextBox 51"/>
+              <a:rPr sz="900" b="1" i="0">
+                <a:solidFill>
+                  <a:srgbClr val="FFFFFF"/>
+                </a:solidFill>
+                <a:latin typeface="Calibri"/>
+              </a:rPr>
+              <a:t>Dziś</a:t>
+            </a:r>
+          </a:p>
+        </p:txBody>
+      </p:sp>
+      <p:sp>
+        <p:nvSpPr>
+          <p:cNvPr id="62" name="TextBox 61"/>
           <p:cNvSpPr txBox="1"/>
           <p:nvPr/>
         </p:nvSpPr>
         <p:spPr>
           <a:xfrm>
-            <a:off x="7315200" y="4937760"/>
-            <a:ext cx="4297680" cy="566928"/>
+            <a:off x="10561320" y="4709160"/>
+            <a:ext cx="1051560" cy="274320"/>
           </a:xfrm>
           <a:prstGeom prst="rect">
             <a:avLst/>
@@ -9962,43 +10364,78 @@
           <a:noFill/>
         </p:spPr>
         <p:txBody>
-          <a:bodyPr wrap="square" anchor="t" lIns="73152" rIns="73152" tIns="36576" bIns="36576">
+          <a:bodyPr wrap="square" anchor="ctr" lIns="73152" rIns="73152" tIns="36576" bIns="36576">
             <a:spAutoFit/>
           </a:bodyPr>
           <a:lstStyle/>
           <a:p>
             <a:pPr algn="l"/>
             <a:r>
-              <a:rPr sz="1100" b="1" i="0">
-                <a:solidFill>
-                  <a:srgbClr val="1C2430"/>
-                </a:solidFill>
-                <a:latin typeface="Calibri"/>
-              </a:rPr>
-              <a:t>Ryzyko nr 1: </a:t>
-            </a:r>
-            <a:r>
-              <a:rPr sz="1050" b="0" i="0">
-                <a:solidFill>
-                  <a:srgbClr val="1C2430"/>
-                </a:solidFill>
-                <a:latin typeface="Calibri"/>
-              </a:rPr>
-              <a:t>lęk o pracę: 82% w OK boi się o stanowisko; lęk najsilniej przewiduje odejście (r = −0,68)</a:t>
-            </a:r>
-          </a:p>
-        </p:txBody>
-      </p:sp>
-      <p:sp>
-        <p:nvSpPr>
-          <p:cNvPr id="53" name="TextBox 52"/>
+              <a:rPr sz="900" b="1" i="0">
+                <a:solidFill>
+                  <a:srgbClr val="FFFFFF"/>
+                </a:solidFill>
+                <a:latin typeface="Calibri"/>
+              </a:rPr>
+              <a:t>Cel 12 mies.</a:t>
+            </a:r>
+          </a:p>
+        </p:txBody>
+      </p:sp>
+      <p:sp>
+        <p:nvSpPr>
+          <p:cNvPr id="63" name="Rectangle 62"/>
+          <p:cNvSpPr/>
+          <p:nvPr/>
+        </p:nvSpPr>
+        <p:spPr>
+          <a:xfrm>
+            <a:off x="7315200" y="5001768"/>
+            <a:ext cx="4297680" cy="384048"/>
+          </a:xfrm>
+          <a:prstGeom prst="rect">
+            <a:avLst/>
+          </a:prstGeom>
+          <a:solidFill>
+            <a:srgbClr val="FFFFFF"/>
+          </a:solidFill>
+          <a:ln>
+            <a:noFill/>
+          </a:ln>
+          <a:effectLst/>
+        </p:spPr>
+        <p:style>
+          <a:lnRef idx="1">
+            <a:schemeClr val="accent1"/>
+          </a:lnRef>
+          <a:fillRef idx="3">
+            <a:schemeClr val="accent1"/>
+          </a:fillRef>
+          <a:effectRef idx="2">
+            <a:schemeClr val="accent1"/>
+          </a:effectRef>
+          <a:fontRef idx="minor">
+            <a:schemeClr val="lt1"/>
+          </a:fontRef>
+        </p:style>
+        <p:txBody>
+          <a:bodyPr rtlCol="0" anchor="ctr"/>
+          <a:lstStyle/>
+          <a:p>
+            <a:pPr algn="ctr"/>
+          </a:p>
+        </p:txBody>
+      </p:sp>
+      <p:sp>
+        <p:nvSpPr>
+          <p:cNvPr id="64" name="TextBox 63"/>
           <p:cNvSpPr txBox="1"/>
           <p:nvPr/>
         </p:nvSpPr>
         <p:spPr>
           <a:xfrm>
-            <a:off x="7315200" y="5541264"/>
-            <a:ext cx="4297680" cy="566928"/>
+            <a:off x="7315200" y="5001768"/>
+            <a:ext cx="2148840" cy="384048"/>
           </a:xfrm>
           <a:prstGeom prst="rect">
             <a:avLst/>
@@ -10006,36 +10443,395 @@
           <a:noFill/>
         </p:spPr>
         <p:txBody>
-          <a:bodyPr wrap="square" anchor="t" lIns="73152" rIns="73152" tIns="36576" bIns="36576">
+          <a:bodyPr wrap="square" anchor="ctr" lIns="73152" rIns="73152" tIns="36576" bIns="36576">
             <a:spAutoFit/>
           </a:bodyPr>
           <a:lstStyle/>
           <a:p>
             <a:pPr algn="l"/>
             <a:r>
-              <a:rPr sz="1100" b="1" i="0">
+              <a:rPr sz="950" b="0" i="0">
                 <a:solidFill>
                   <a:srgbClr val="1C2430"/>
                 </a:solidFill>
                 <a:latin typeface="Calibri"/>
               </a:rPr>
-              <a:t>3 KPI na 12 mies.: </a:t>
-            </a:r>
-            <a:r>
-              <a:rPr sz="1050" b="0" i="0">
+              <a:t>Wynik: SLA NORDY · kary NORDA + Lumea</a:t>
+            </a:r>
+          </a:p>
+        </p:txBody>
+      </p:sp>
+      <p:sp>
+        <p:nvSpPr>
+          <p:cNvPr id="65" name="TextBox 64"/>
+          <p:cNvSpPr txBox="1"/>
+          <p:nvPr/>
+        </p:nvSpPr>
+        <p:spPr>
+          <a:xfrm>
+            <a:off x="9464040" y="5001768"/>
+            <a:ext cx="1097280" cy="384048"/>
+          </a:xfrm>
+          <a:prstGeom prst="rect">
+            <a:avLst/>
+          </a:prstGeom>
+          <a:noFill/>
+        </p:spPr>
+        <p:txBody>
+          <a:bodyPr wrap="square" anchor="ctr" lIns="73152" rIns="73152" tIns="36576" bIns="36576">
+            <a:spAutoFit/>
+          </a:bodyPr>
+          <a:lstStyle/>
+          <a:p>
+            <a:pPr algn="l"/>
+            <a:r>
+              <a:rPr sz="950" b="0" i="0">
                 <a:solidFill>
                   <a:srgbClr val="1C2430"/>
                 </a:solidFill>
                 <a:latin typeface="Calibri"/>
               </a:rPr>
-              <a:t>SLA OK 92,1% → [cel] · błędy reklamacji 6,9% → &lt; 4% · rotacja OK 24,5% → [cel]</a:t>
-            </a:r>
-          </a:p>
-        </p:txBody>
-      </p:sp>
-      <p:sp>
-        <p:nvSpPr>
-          <p:cNvPr id="54" name="Rectangle 53"/>
+              <a:t>91,0% · 5,92 mln</a:t>
+            </a:r>
+          </a:p>
+        </p:txBody>
+      </p:sp>
+      <p:sp>
+        <p:nvSpPr>
+          <p:cNvPr id="66" name="TextBox 65"/>
+          <p:cNvSpPr txBox="1"/>
+          <p:nvPr/>
+        </p:nvSpPr>
+        <p:spPr>
+          <a:xfrm>
+            <a:off x="10561320" y="5001768"/>
+            <a:ext cx="1051560" cy="384048"/>
+          </a:xfrm>
+          <a:prstGeom prst="rect">
+            <a:avLst/>
+          </a:prstGeom>
+          <a:noFill/>
+        </p:spPr>
+        <p:txBody>
+          <a:bodyPr wrap="square" anchor="ctr" lIns="73152" rIns="73152" tIns="36576" bIns="36576">
+            <a:spAutoFit/>
+          </a:bodyPr>
+          <a:lstStyle/>
+          <a:p>
+            <a:pPr algn="l"/>
+            <a:r>
+              <a:rPr sz="950" b="1" i="0">
+                <a:solidFill>
+                  <a:srgbClr val="0F7C7E"/>
+                </a:solidFill>
+                <a:latin typeface="Calibri"/>
+              </a:rPr>
+              <a:t>≥ 95% · −50%</a:t>
+            </a:r>
+          </a:p>
+        </p:txBody>
+      </p:sp>
+      <p:sp>
+        <p:nvSpPr>
+          <p:cNvPr id="67" name="Rectangle 66"/>
+          <p:cNvSpPr/>
+          <p:nvPr/>
+        </p:nvSpPr>
+        <p:spPr>
+          <a:xfrm>
+            <a:off x="7315200" y="5404104"/>
+            <a:ext cx="4297680" cy="384048"/>
+          </a:xfrm>
+          <a:prstGeom prst="rect">
+            <a:avLst/>
+          </a:prstGeom>
+          <a:solidFill>
+            <a:srgbClr val="F3F5F8"/>
+          </a:solidFill>
+          <a:ln>
+            <a:noFill/>
+          </a:ln>
+          <a:effectLst/>
+        </p:spPr>
+        <p:style>
+          <a:lnRef idx="1">
+            <a:schemeClr val="accent1"/>
+          </a:lnRef>
+          <a:fillRef idx="3">
+            <a:schemeClr val="accent1"/>
+          </a:fillRef>
+          <a:effectRef idx="2">
+            <a:schemeClr val="accent1"/>
+          </a:effectRef>
+          <a:fontRef idx="minor">
+            <a:schemeClr val="lt1"/>
+          </a:fontRef>
+        </p:style>
+        <p:txBody>
+          <a:bodyPr rtlCol="0" anchor="ctr"/>
+          <a:lstStyle/>
+          <a:p>
+            <a:pPr algn="ctr"/>
+          </a:p>
+        </p:txBody>
+      </p:sp>
+      <p:sp>
+        <p:nvSpPr>
+          <p:cNvPr id="68" name="TextBox 67"/>
+          <p:cNvSpPr txBox="1"/>
+          <p:nvPr/>
+        </p:nvSpPr>
+        <p:spPr>
+          <a:xfrm>
+            <a:off x="7315200" y="5404104"/>
+            <a:ext cx="2148840" cy="384048"/>
+          </a:xfrm>
+          <a:prstGeom prst="rect">
+            <a:avLst/>
+          </a:prstGeom>
+          <a:noFill/>
+        </p:spPr>
+        <p:txBody>
+          <a:bodyPr wrap="square" anchor="ctr" lIns="73152" rIns="73152" tIns="36576" bIns="36576">
+            <a:spAutoFit/>
+          </a:bodyPr>
+          <a:lstStyle/>
+          <a:p>
+            <a:pPr algn="l"/>
+            <a:r>
+              <a:rPr sz="950" b="0" i="0">
+                <a:solidFill>
+                  <a:srgbClr val="1C2430"/>
+                </a:solidFill>
+                <a:latin typeface="Calibri"/>
+              </a:rPr>
+              <a:t>Adopcja: aktywne konta AI · przeszkoleni OK</a:t>
+            </a:r>
+          </a:p>
+        </p:txBody>
+      </p:sp>
+      <p:sp>
+        <p:nvSpPr>
+          <p:cNvPr id="69" name="TextBox 68"/>
+          <p:cNvSpPr txBox="1"/>
+          <p:nvPr/>
+        </p:nvSpPr>
+        <p:spPr>
+          <a:xfrm>
+            <a:off x="9464040" y="5404104"/>
+            <a:ext cx="1097280" cy="384048"/>
+          </a:xfrm>
+          <a:prstGeom prst="rect">
+            <a:avLst/>
+          </a:prstGeom>
+          <a:noFill/>
+        </p:spPr>
+        <p:txBody>
+          <a:bodyPr wrap="square" anchor="ctr" lIns="73152" rIns="73152" tIns="36576" bIns="36576">
+            <a:spAutoFit/>
+          </a:bodyPr>
+          <a:lstStyle/>
+          <a:p>
+            <a:pPr algn="l"/>
+            <a:r>
+              <a:rPr sz="950" b="0" i="0">
+                <a:solidFill>
+                  <a:srgbClr val="1C2430"/>
+                </a:solidFill>
+                <a:latin typeface="Calibri"/>
+              </a:rPr>
+              <a:t>pomiar mies. 1 · 9%</a:t>
+            </a:r>
+          </a:p>
+        </p:txBody>
+      </p:sp>
+      <p:sp>
+        <p:nvSpPr>
+          <p:cNvPr id="70" name="TextBox 69"/>
+          <p:cNvSpPr txBox="1"/>
+          <p:nvPr/>
+        </p:nvSpPr>
+        <p:spPr>
+          <a:xfrm>
+            <a:off x="10561320" y="5404104"/>
+            <a:ext cx="1051560" cy="384048"/>
+          </a:xfrm>
+          <a:prstGeom prst="rect">
+            <a:avLst/>
+          </a:prstGeom>
+          <a:noFill/>
+        </p:spPr>
+        <p:txBody>
+          <a:bodyPr wrap="square" anchor="ctr" lIns="73152" rIns="73152" tIns="36576" bIns="36576">
+            <a:spAutoFit/>
+          </a:bodyPr>
+          <a:lstStyle/>
+          <a:p>
+            <a:pPr algn="l"/>
+            <a:r>
+              <a:rPr sz="950" b="1" i="0">
+                <a:solidFill>
+                  <a:srgbClr val="0F7C7E"/>
+                </a:solidFill>
+                <a:latin typeface="Calibri"/>
+              </a:rPr>
+              <a:t>≥ 80% · 100%</a:t>
+            </a:r>
+          </a:p>
+        </p:txBody>
+      </p:sp>
+      <p:sp>
+        <p:nvSpPr>
+          <p:cNvPr id="71" name="Rectangle 70"/>
+          <p:cNvSpPr/>
+          <p:nvPr/>
+        </p:nvSpPr>
+        <p:spPr>
+          <a:xfrm>
+            <a:off x="7315200" y="5806440"/>
+            <a:ext cx="4297680" cy="384048"/>
+          </a:xfrm>
+          <a:prstGeom prst="rect">
+            <a:avLst/>
+          </a:prstGeom>
+          <a:solidFill>
+            <a:srgbClr val="FFFFFF"/>
+          </a:solidFill>
+          <a:ln>
+            <a:noFill/>
+          </a:ln>
+          <a:effectLst/>
+        </p:spPr>
+        <p:style>
+          <a:lnRef idx="1">
+            <a:schemeClr val="accent1"/>
+          </a:lnRef>
+          <a:fillRef idx="3">
+            <a:schemeClr val="accent1"/>
+          </a:fillRef>
+          <a:effectRef idx="2">
+            <a:schemeClr val="accent1"/>
+          </a:effectRef>
+          <a:fontRef idx="minor">
+            <a:schemeClr val="lt1"/>
+          </a:fontRef>
+        </p:style>
+        <p:txBody>
+          <a:bodyPr rtlCol="0" anchor="ctr"/>
+          <a:lstStyle/>
+          <a:p>
+            <a:pPr algn="ctr"/>
+          </a:p>
+        </p:txBody>
+      </p:sp>
+      <p:sp>
+        <p:nvSpPr>
+          <p:cNvPr id="72" name="TextBox 71"/>
+          <p:cNvSpPr txBox="1"/>
+          <p:nvPr/>
+        </p:nvSpPr>
+        <p:spPr>
+          <a:xfrm>
+            <a:off x="7315200" y="5806440"/>
+            <a:ext cx="2148840" cy="384048"/>
+          </a:xfrm>
+          <a:prstGeom prst="rect">
+            <a:avLst/>
+          </a:prstGeom>
+          <a:noFill/>
+        </p:spPr>
+        <p:txBody>
+          <a:bodyPr wrap="square" anchor="ctr" lIns="73152" rIns="73152" tIns="36576" bIns="36576">
+            <a:spAutoFit/>
+          </a:bodyPr>
+          <a:lstStyle/>
+          <a:p>
+            <a:pPr algn="l"/>
+            <a:r>
+              <a:rPr sz="950" b="0" i="0">
+                <a:solidFill>
+                  <a:srgbClr val="1C2430"/>
+                </a:solidFill>
+                <a:latin typeface="Calibri"/>
+              </a:rPr>
+              <a:t>Ludzie: obawa o pracę OK (Q20) · rotacja OK</a:t>
+            </a:r>
+          </a:p>
+        </p:txBody>
+      </p:sp>
+      <p:sp>
+        <p:nvSpPr>
+          <p:cNvPr id="73" name="TextBox 72"/>
+          <p:cNvSpPr txBox="1"/>
+          <p:nvPr/>
+        </p:nvSpPr>
+        <p:spPr>
+          <a:xfrm>
+            <a:off x="9464040" y="5806440"/>
+            <a:ext cx="1097280" cy="384048"/>
+          </a:xfrm>
+          <a:prstGeom prst="rect">
+            <a:avLst/>
+          </a:prstGeom>
+          <a:noFill/>
+        </p:spPr>
+        <p:txBody>
+          <a:bodyPr wrap="square" anchor="ctr" lIns="73152" rIns="73152" tIns="36576" bIns="36576">
+            <a:spAutoFit/>
+          </a:bodyPr>
+          <a:lstStyle/>
+          <a:p>
+            <a:pPr algn="l"/>
+            <a:r>
+              <a:rPr sz="950" b="0" i="0">
+                <a:solidFill>
+                  <a:srgbClr val="1C2430"/>
+                </a:solidFill>
+                <a:latin typeface="Calibri"/>
+              </a:rPr>
+              <a:t>4,2 · 24,5%</a:t>
+            </a:r>
+          </a:p>
+        </p:txBody>
+      </p:sp>
+      <p:sp>
+        <p:nvSpPr>
+          <p:cNvPr id="74" name="TextBox 73"/>
+          <p:cNvSpPr txBox="1"/>
+          <p:nvPr/>
+        </p:nvSpPr>
+        <p:spPr>
+          <a:xfrm>
+            <a:off x="10561320" y="5806440"/>
+            <a:ext cx="1051560" cy="384048"/>
+          </a:xfrm>
+          <a:prstGeom prst="rect">
+            <a:avLst/>
+          </a:prstGeom>
+          <a:noFill/>
+        </p:spPr>
+        <p:txBody>
+          <a:bodyPr wrap="square" anchor="ctr" lIns="73152" rIns="73152" tIns="36576" bIns="36576">
+            <a:spAutoFit/>
+          </a:bodyPr>
+          <a:lstStyle/>
+          <a:p>
+            <a:pPr algn="l"/>
+            <a:r>
+              <a:rPr sz="950" b="1" i="0">
+                <a:solidFill>
+                  <a:srgbClr val="0F7C7E"/>
+                </a:solidFill>
+                <a:latin typeface="Calibri"/>
+              </a:rPr>
+              <a:t>≤ 3,5 · ≤ 20%</a:t>
+            </a:r>
+          </a:p>
+        </p:txBody>
+      </p:sp>
+      <p:sp>
+        <p:nvSpPr>
+          <p:cNvPr id="75" name="Rectangle 74"/>
           <p:cNvSpPr/>
           <p:nvPr/>
         </p:nvSpPr>
@@ -10079,7 +10875,7 @@
       </p:sp>
       <p:sp>
         <p:nvSpPr>
-          <p:cNvPr id="55" name="TextBox 54"/>
+          <p:cNvPr id="76" name="TextBox 75"/>
           <p:cNvSpPr txBox="1"/>
           <p:nvPr/>
         </p:nvSpPr>
@@ -10107,7 +10903,62 @@
                 </a:solidFill>
                 <a:latin typeface="Calibri"/>
               </a:rPr>
-              <a:t>* Hipoteza zespołu (3B, kol. H): P-014 −30%, P-012 −30%, P-001 −50% godzin z 3A; 1 etat = 160 h/m. Źródła: Etap 3 — 3B (wybór, licencje, rok 1), 3C (mapa HITL P-014), 3D (cennik); ankieta Q14, Q20, Q26.</a:t>
+              <a:t>* Hipoteza zespołu (3B, kol. H): P-014 −30%, P-012 −30%, P-001 −50% godzin z 3A; 1 etat = 160 h/m. Źródła: Etap 3 — 3B, 3C, 3D; Etap 4 — 4A (role), 4B (fazy, bramy), 4C (KPI); Historia_miesieczna, Klienci, Działy; ankieta Q15–Q21.</a:t>
+            </a:r>
+          </a:p>
+        </p:txBody>
+      </p:sp>
+      <p:sp>
+        <p:nvSpPr>
+          <p:cNvPr id="77" name="Rounded Rectangle 76"/>
+          <p:cNvSpPr/>
+          <p:nvPr/>
+        </p:nvSpPr>
+        <p:spPr>
+          <a:xfrm>
+            <a:off x="9555480" y="6455664"/>
+            <a:ext cx="2130552" cy="256032"/>
+          </a:xfrm>
+          <a:prstGeom prst="roundRect">
+            <a:avLst/>
+          </a:prstGeom>
+          <a:solidFill>
+            <a:srgbClr val="FDF3E1"/>
+          </a:solidFill>
+          <a:ln w="9525">
+            <a:solidFill>
+              <a:srgbClr val="C77C0E"/>
+            </a:solidFill>
+          </a:ln>
+          <a:effectLst/>
+        </p:spPr>
+        <p:style>
+          <a:lnRef idx="1">
+            <a:schemeClr val="accent1"/>
+          </a:lnRef>
+          <a:fillRef idx="3">
+            <a:schemeClr val="accent1"/>
+          </a:fillRef>
+          <a:effectRef idx="2">
+            <a:schemeClr val="accent1"/>
+          </a:effectRef>
+          <a:fontRef idx="minor">
+            <a:schemeClr val="lt1"/>
+          </a:fontRef>
+        </p:style>
+        <p:txBody>
+          <a:bodyPr rtlCol="0" anchor="ctr" wrap="square" lIns="73152" rIns="73152" tIns="36576" bIns="36576"/>
+          <a:lstStyle/>
+          <a:p>
+            <a:pPr algn="ctr"/>
+            <a:r>
+              <a:rPr sz="900" b="1" i="0">
+                <a:solidFill>
+                  <a:srgbClr val="C77C0E"/>
+                </a:solidFill>
+                <a:latin typeface="Calibri"/>
+              </a:rPr>
+              <a:t>36 ET. — SPRAWDŹ 3A (E4)</a:t>
             </a:r>
           </a:p>
         </p:txBody>

</xml_diff>